<commit_message>
Uploaded fixed slides and video
</commit_message>
<xml_diff>
--- a/shopper_archetypes_pitch.pptx
+++ b/shopper_archetypes_pitch.pptx
@@ -1707,7 +1707,7 @@
                 <a:ea typeface="Georgia" pitchFamily="34" charset="-122"/>
                 <a:cs typeface="Georgia" pitchFamily="34" charset="-120"/>
               </a:rPr>
-              <a:t>and everyone is competing on the same thing.</a:t>
+              <a:t>and everyone's racing to predict the next item in your cart.</a:t>
             </a:r>
             <a:endParaRPr lang="en-US" sz="2200" dirty="0"/>
           </a:p>
@@ -1914,7 +1914,7 @@
                 <a:ea typeface="Calibri" pitchFamily="34" charset="-122"/>
                 <a:cs typeface="Calibri" pitchFamily="34" charset="-120"/>
               </a:rPr>
-              <a:t>ALL COMPETING ON ONE THING:</a:t>
+              <a:t>ALL RECOMMEND THE SAME WAY — MINING THESE THREE SIGNALS:</a:t>
             </a:r>
             <a:endParaRPr lang="en-US" sz="1000" dirty="0"/>
           </a:p>
@@ -1928,8 +1928,8 @@
         </p:nvSpPr>
         <p:spPr>
           <a:xfrm>
-            <a:off x="548640" y="4251960"/>
-            <a:ext cx="8046720" cy="457200"/>
+            <a:off x="594360" y="4297680"/>
+            <a:ext cx="2560320" cy="457200"/>
           </a:xfrm>
           <a:prstGeom prst="rect">
             <a:avLst/>
@@ -1945,7 +1945,7 @@
               <a:buNone/>
             </a:pPr>
             <a:r>
-              <a:rPr lang="en-US" sz="2200" b="1" i="1" dirty="0">
+              <a:rPr lang="en-US" sz="1400" b="1" i="1" dirty="0">
                 <a:solidFill>
                   <a:srgbClr val="C8102E"/>
                 </a:solidFill>
@@ -1953,9 +1953,87 @@
                 <a:ea typeface="Georgia" pitchFamily="34" charset="-122"/>
                 <a:cs typeface="Georgia" pitchFamily="34" charset="-120"/>
               </a:rPr>
-              <a:t>Predicting what you'll put in your cart next.</a:t>
-            </a:r>
-            <a:endParaRPr lang="en-US" sz="2200" dirty="0"/>
+              <a:t>What people buy together</a:t>
+            </a:r>
+            <a:endParaRPr lang="en-US" sz="1400" dirty="0"/>
+          </a:p>
+        </p:txBody>
+      </p:sp>
+      <p:sp>
+        <p:nvSpPr>
+          <p:cNvPr id="13" name="Text 8"/>
+          <p:cNvSpPr/>
+          <p:nvPr/>
+        </p:nvSpPr>
+        <p:spPr>
+          <a:xfrm>
+            <a:off x="3291840" y="4297680"/>
+            <a:ext cx="2560320" cy="457200"/>
+          </a:xfrm>
+          <a:prstGeom prst="rect">
+            <a:avLst/>
+          </a:prstGeom>
+          <a:noFill/>
+          <a:ln/>
+        </p:spPr>
+        <p:txBody>
+          <a:bodyPr wrap="square" lIns="0" tIns="0" rIns="0" bIns="0" rtlCol="0" anchor="ctr"/>
+          <a:lstStyle/>
+          <a:p>
+            <a:pPr algn="ctr" indent="0" marL="0">
+              <a:buNone/>
+            </a:pPr>
+            <a:r>
+              <a:rPr lang="en-US" sz="1400" b="1" i="1" dirty="0">
+                <a:solidFill>
+                  <a:srgbClr val="C8102E"/>
+                </a:solidFill>
+                <a:latin typeface="Georgia" pitchFamily="34" charset="0"/>
+                <a:ea typeface="Georgia" pitchFamily="34" charset="-122"/>
+                <a:cs typeface="Georgia" pitchFamily="34" charset="-120"/>
+              </a:rPr>
+              <a:t>What you've bought before</a:t>
+            </a:r>
+            <a:endParaRPr lang="en-US" sz="1400" dirty="0"/>
+          </a:p>
+        </p:txBody>
+      </p:sp>
+      <p:sp>
+        <p:nvSpPr>
+          <p:cNvPr id="14" name="Text 9"/>
+          <p:cNvSpPr/>
+          <p:nvPr/>
+        </p:nvSpPr>
+        <p:spPr>
+          <a:xfrm>
+            <a:off x="5989320" y="4297680"/>
+            <a:ext cx="2560320" cy="457200"/>
+          </a:xfrm>
+          <a:prstGeom prst="rect">
+            <a:avLst/>
+          </a:prstGeom>
+          <a:noFill/>
+          <a:ln/>
+        </p:spPr>
+        <p:txBody>
+          <a:bodyPr wrap="square" lIns="0" tIns="0" rIns="0" bIns="0" rtlCol="0" anchor="ctr"/>
+          <a:lstStyle/>
+          <a:p>
+            <a:pPr algn="ctr" indent="0" marL="0">
+              <a:buNone/>
+            </a:pPr>
+            <a:r>
+              <a:rPr lang="en-US" sz="1400" b="1" i="1" dirty="0">
+                <a:solidFill>
+                  <a:srgbClr val="C8102E"/>
+                </a:solidFill>
+                <a:latin typeface="Georgia" pitchFamily="34" charset="0"/>
+                <a:ea typeface="Georgia" pitchFamily="34" charset="-122"/>
+                <a:cs typeface="Georgia" pitchFamily="34" charset="-120"/>
+              </a:rPr>
+              <a:t>When you tend to shop</a:t>
+            </a:r>
+            <a:endParaRPr lang="en-US" sz="1400" dirty="0"/>
           </a:p>
         </p:txBody>
       </p:sp>
@@ -2611,7 +2689,7 @@
                 <a:ea typeface="Calibri" pitchFamily="34" charset="-122"/>
                 <a:cs typeface="Calibri" pitchFamily="34" charset="-120"/>
               </a:rPr>
-              <a:t>Tune support thresholds</a:t>
+              <a:t>Split by time of day</a:t>
             </a:r>
             <a:endParaRPr lang="en-US" sz="1600" dirty="0"/>
           </a:p>
@@ -2650,7 +2728,7 @@
                 <a:ea typeface="Calibri" pitchFamily="34" charset="-122"/>
                 <a:cs typeface="Calibri" pitchFamily="34" charset="-120"/>
               </a:rPr>
-              <a:t>Rule density vs. signal trade-off</a:t>
+              <a:t>Morning vs. afternoon vs. evening</a:t>
             </a:r>
             <a:endParaRPr lang="en-US" sz="1100" dirty="0"/>
           </a:p>
@@ -2752,7 +2830,7 @@
                 <a:ea typeface="Calibri" pitchFamily="34" charset="-122"/>
                 <a:cs typeface="Calibri" pitchFamily="34" charset="-120"/>
               </a:rPr>
-              <a:t>Segment by time of day</a:t>
+              <a:t>Split by weekend vs. weekday</a:t>
             </a:r>
             <a:endParaRPr lang="en-US" sz="1600" dirty="0"/>
           </a:p>
@@ -2791,7 +2869,7 @@
                 <a:ea typeface="Calibri" pitchFamily="34" charset="-122"/>
                 <a:cs typeface="Calibri" pitchFamily="34" charset="-120"/>
               </a:rPr>
-              <a:t>Weekend vs. weekday, morning vs. evening</a:t>
+              <a:t>Day-of-week context</a:t>
             </a:r>
             <a:endParaRPr lang="en-US" sz="1100" dirty="0"/>
           </a:p>
@@ -2893,7 +2971,7 @@
                 <a:ea typeface="Calibri" pitchFamily="34" charset="-122"/>
                 <a:cs typeface="Calibri" pitchFamily="34" charset="-120"/>
               </a:rPr>
-              <a:t>Track order sequences</a:t>
+              <a:t>Split by sequence of orders</a:t>
             </a:r>
             <a:endParaRPr lang="en-US" sz="1600" dirty="0"/>
           </a:p>
@@ -2932,7 +3010,7 @@
                 <a:ea typeface="Calibri" pitchFamily="34" charset="-122"/>
                 <a:cs typeface="Calibri" pitchFamily="34" charset="-120"/>
               </a:rPr>
-              <a:t>Sequential pattern mining (PrefixSpan)</a:t>
+              <a:t>What's typically bought across visits</a:t>
             </a:r>
             <a:endParaRPr lang="en-US" sz="1100" dirty="0"/>
           </a:p>
@@ -3059,7 +3137,7 @@
                 <a:ea typeface="Calibri" pitchFamily="34" charset="-122"/>
                 <a:cs typeface="Calibri" pitchFamily="34" charset="-120"/>
               </a:rPr>
-              <a:t>Segment by shopper archetype</a:t>
+              <a:t>Split by shopper archetype</a:t>
             </a:r>
             <a:endParaRPr lang="en-US" sz="1600" dirty="0"/>
           </a:p>
@@ -3098,7 +3176,7 @@
                 <a:ea typeface="Calibri" pitchFamily="34" charset="-122"/>
                 <a:cs typeface="Calibri" pitchFamily="34" charset="-120"/>
               </a:rPr>
-              <a:t>Cluster by what they actually buy</a:t>
+              <a:t>Let the data group customers first</a:t>
             </a:r>
             <a:endParaRPr lang="en-US" sz="1100" dirty="0"/>
           </a:p>
@@ -3688,7 +3766,7 @@
                 <a:ea typeface="Calibri" pitchFamily="34" charset="-122"/>
                 <a:cs typeface="Calibri" pitchFamily="34" charset="-120"/>
               </a:rPr>
-              <a:t>HOW MUCH EACH GROUPING DIFFERENTIATES CUSTOMER BUYING PATTERNS</a:t>
+              <a:t>HOW MUCH EACH LENS CHANGED THE DISCOVERED PATTERNS</a:t>
             </a:r>
             <a:endParaRPr lang="en-US" sz="1000" dirty="0"/>
           </a:p>
@@ -3830,7 +3908,7 @@
                 <a:ea typeface="Calibri" pitchFamily="34" charset="-122"/>
                 <a:cs typeface="Calibri" pitchFamily="34" charset="-120"/>
               </a:rPr>
-              <a:t>differentiation</a:t>
+              <a:t>of patterns changed</a:t>
             </a:r>
             <a:endParaRPr lang="en-US" sz="1100" dirty="0"/>
           </a:p>
@@ -4011,7 +4089,7 @@
                 <a:ea typeface="Calibri" pitchFamily="34" charset="-122"/>
                 <a:cs typeface="Calibri" pitchFamily="34" charset="-120"/>
               </a:rPr>
-              <a:t>differentiation</a:t>
+              <a:t>of patterns changed</a:t>
             </a:r>
             <a:endParaRPr lang="en-US" sz="1100" dirty="0"/>
           </a:p>
@@ -4192,7 +4270,7 @@
                 <a:ea typeface="Calibri" pitchFamily="34" charset="-122"/>
                 <a:cs typeface="Calibri" pitchFamily="34" charset="-120"/>
               </a:rPr>
-              <a:t>differentiation</a:t>
+              <a:t>of patterns changed</a:t>
             </a:r>
             <a:endParaRPr lang="en-US" sz="1100" dirty="0"/>
           </a:p>
@@ -4270,7 +4348,7 @@
                 <a:ea typeface="Georgia" pitchFamily="34" charset="-122"/>
                 <a:cs typeface="Georgia" pitchFamily="34" charset="-120"/>
               </a:rPr>
-              <a:t>Archetypes differentiate buying patterns 2× more than the strongest alternative.</a:t>
+              <a:t>The universal-pattern assumption breaks when you split by shopper type.</a:t>
             </a:r>
             <a:endParaRPr lang="en-US" sz="1400" dirty="0"/>
           </a:p>
@@ -4623,7 +4701,7 @@
                 <a:ea typeface="Calibri" pitchFamily="34" charset="-122"/>
                 <a:cs typeface="Calibri" pitchFamily="34" charset="-120"/>
               </a:rPr>
-              <a:t>Understanding who your customer actually is —</a:t>
+              <a:t>Personalization has to start with who your customer is —</a:t>
             </a:r>
             <a:endParaRPr lang="en-US" sz="1800" dirty="0"/>
           </a:p>
@@ -4662,7 +4740,7 @@
                 <a:ea typeface="Calibri" pitchFamily="34" charset="-122"/>
                 <a:cs typeface="Calibri" pitchFamily="34" charset="-120"/>
               </a:rPr>
-              <a:t>before anyone else does.</a:t>
+              <a:t>before anyone else figures that out.</a:t>
             </a:r>
             <a:endParaRPr lang="en-US" sz="1800" dirty="0"/>
           </a:p>

</xml_diff>